<commit_message>
docs(platform): document managed proof and wallet operation
</commit_message>
<xml_diff>
--- a/docs/submission/deck/bacchiri-verifiable-measurement-layer-wave1-en.pptx
+++ b/docs/submission/deck/bacchiri-verifiable-measurement-layer-wave1-en.pptx
@@ -1038,7 +1038,7 @@
           <a:p>
             <a:r>
               <a:rPr lang="en-US" dirty="0"/>
-              <a:t/>
+              <a:t>Our engineering innovation: 24/7 admission with an on-demand server-side Sponsor Wallet that restores an encrypted checkpoint, waits for synchronization, adds only DUST to an already-authorized transaction, and stops gracefully. The standard-4 planning example compares USD 133.23 for 720 active hours with USD 22.20 for an illustrative 120-hour monthly drain, an estimated 83.3 percent reduction; other Cloudflare services and the Proof Server are excluded.</a:t>
             </a:r>
             <a:endParaRPr lang="en-US" dirty="0"/>
           </a:p>
@@ -4411,14 +4411,7 @@
 
 <file path=ppt/slides/slide7.xml><?xml version="1.0" encoding="utf-8"?>
 <p:sld xmlns:a="http://schemas.openxmlformats.org/drawingml/2006/main" xmlns:r="http://schemas.openxmlformats.org/officeDocument/2006/relationships" xmlns:p="http://schemas.openxmlformats.org/presentationml/2006/main">
-  <p:cSld name="Slide 7">
-    <p:bg>
-      <p:bgPr>
-        <a:solidFill>
-          <a:srgbClr val="090D2F"/>
-        </a:solidFill>
-      </p:bgPr>
-    </p:bg>
+  <p:cSld>
     <p:spTree>
       <p:nvGrpSpPr>
         <p:cNvPr id="1" name=""/>
@@ -4433,180 +4426,9 @@
           <a:chExt cx="0" cy="0"/>
         </a:xfrm>
       </p:grpSpPr>
-      <p:sp>
-        <p:nvSpPr>
-          <p:cNvPr id="2" name="Text 0"/>
-          <p:cNvSpPr/>
-          <p:nvPr/>
-        </p:nvSpPr>
-        <p:spPr>
-          <a:xfrm>
-            <a:off x="502920" y="320040"/>
-            <a:ext cx="4114800" cy="201168"/>
-          </a:xfrm>
-          <a:prstGeom prst="rect">
-            <a:avLst/>
-          </a:prstGeom>
-          <a:noFill/>
-          <a:ln/>
-        </p:spPr>
-        <p:txBody>
-          <a:bodyPr wrap="square" lIns="0" tIns="0" rIns="0" bIns="0" rtlCol="0" anchor="ctr"/>
-          <a:lstStyle/>
-          <a:p>
-            <a:pPr indent="0" marL="0">
-              <a:buNone/>
-            </a:pPr>
-            <a:r>
-              <a:rPr lang="en-US" sz="900" b="1" spc="140" kern="0" dirty="0">
-                <a:solidFill>
-                  <a:srgbClr val="75F3E5"/>
-                </a:solidFill>
-              </a:rPr>
-              <a:t>LIVE PRODUCT · STEP 3</a:t>
-            </a:r>
-            <a:endParaRPr lang="en-US" sz="900" dirty="0"/>
-          </a:p>
-        </p:txBody>
-      </p:sp>
-      <p:sp>
-        <p:nvSpPr>
-          <p:cNvPr id="3" name="Text 1"/>
-          <p:cNvSpPr/>
-          <p:nvPr/>
-        </p:nvSpPr>
-        <p:spPr>
-          <a:xfrm>
-            <a:off x="502920" y="640080"/>
-            <a:ext cx="11155680" cy="502920"/>
-          </a:xfrm>
-          <a:prstGeom prst="rect">
-            <a:avLst/>
-          </a:prstGeom>
-          <a:noFill/>
-          <a:ln/>
-        </p:spPr>
-        <p:txBody>
-          <a:bodyPr wrap="square" lIns="0" tIns="0" rIns="0" bIns="0" rtlCol="0" anchor="ctr">
-            <a:normAutofit/>
-          </a:bodyPr>
-          <a:lstStyle/>
-          <a:p>
-            <a:pPr indent="0" marL="0">
-              <a:buNone/>
-            </a:pPr>
-            <a:r>
-              <a:rPr lang="en-US" sz="2800" b="1" dirty="0">
-                <a:solidFill>
-                  <a:srgbClr val="FFFFFF"/>
-                </a:solidFill>
-              </a:rPr>
-              <a:t>Separate approval authority from fee payment</a:t>
-            </a:r>
-            <a:endParaRPr lang="en-US" sz="2800" dirty="0"/>
-          </a:p>
-        </p:txBody>
-      </p:sp>
-      <p:sp>
-        <p:nvSpPr>
-          <p:cNvPr id="4" name="Text 2"/>
-          <p:cNvSpPr/>
-          <p:nvPr/>
-        </p:nvSpPr>
-        <p:spPr>
-          <a:xfrm>
-            <a:off x="521208" y="1234440"/>
-            <a:ext cx="10881360" cy="320040"/>
-          </a:xfrm>
-          <a:prstGeom prst="rect">
-            <a:avLst/>
-          </a:prstGeom>
-          <a:noFill/>
-          <a:ln/>
-        </p:spPr>
-        <p:txBody>
-          <a:bodyPr wrap="square" lIns="0" tIns="0" rIns="0" bIns="0" rtlCol="0" anchor="ctr">
-            <a:normAutofit/>
-          </a:bodyPr>
-          <a:lstStyle/>
-          <a:p>
-            <a:pPr indent="0" marL="0">
-              <a:buNone/>
-            </a:pPr>
-            <a:r>
-              <a:rPr lang="en-US" sz="1250" dirty="0">
-                <a:solidFill>
-                  <a:srgbClr val="BBC4E8"/>
-                </a:solidFill>
-              </a:rPr>
-              <a:t>The Device approves the exact payload. A separate Sponsor Wallet contributes only the DUST required for submission.</a:t>
-            </a:r>
-            <a:endParaRPr lang="en-US" sz="1250" dirty="0"/>
-          </a:p>
-        </p:txBody>
-      </p:sp>
-      <p:sp>
-        <p:nvSpPr>
-          <p:cNvPr id="5" name="Shape 3"/>
-          <p:cNvSpPr/>
-          <p:nvPr/>
-        </p:nvSpPr>
-        <p:spPr>
-          <a:xfrm>
-            <a:off x="502920" y="6519672"/>
-            <a:ext cx="11155680" cy="0"/>
-          </a:xfrm>
-          <a:prstGeom prst="line">
-            <a:avLst/>
-          </a:prstGeom>
-          <a:noFill/>
-          <a:ln w="12700">
-            <a:solidFill>
-              <a:srgbClr val="29356B"/>
-            </a:solidFill>
-            <a:prstDash val="solid"/>
-          </a:ln>
-        </p:spPr>
-      </p:sp>
-      <p:sp>
-        <p:nvSpPr>
-          <p:cNvPr id="6" name="Text 4"/>
-          <p:cNvSpPr/>
-          <p:nvPr/>
-        </p:nvSpPr>
-        <p:spPr>
-          <a:xfrm>
-            <a:off x="530352" y="6583680"/>
-            <a:ext cx="3657600" cy="109728"/>
-          </a:xfrm>
-          <a:prstGeom prst="rect">
-            <a:avLst/>
-          </a:prstGeom>
-          <a:noFill/>
-          <a:ln/>
-        </p:spPr>
-        <p:txBody>
-          <a:bodyPr wrap="square" lIns="0" tIns="0" rIns="0" bIns="0" rtlCol="0" anchor="ctr"/>
-          <a:lstStyle/>
-          <a:p>
-            <a:pPr indent="0" marL="0">
-              <a:buNone/>
-            </a:pPr>
-            <a:r>
-              <a:rPr lang="en-US" sz="650" dirty="0">
-                <a:solidFill>
-                  <a:srgbClr val="BBC4E8"/>
-                </a:solidFill>
-              </a:rPr>
-              <a:t>BACCHIRI! · MIDNIGHT BUILDATHON</a:t>
-            </a:r>
-            <a:endParaRPr lang="en-US" sz="650" dirty="0"/>
-          </a:p>
-        </p:txBody>
-      </p:sp>
       <p:pic>
         <p:nvPicPr>
-          <p:cNvPr id="7" name="Image 0" descr="/home/polonity/workspace/midnight/midnight_cloudflare_demo/.demo-output/submission-en-20260831/deck-assets/approval.png">    </p:cNvPr>
+          <p:cNvPr id="2" name="On-demand Sponsor Wallet architecture" descr="Our engineering innovation: 24/7 admission with an on-demand server-side Sponsor Wallet that restores an encrypted checkpoint, waits for synchronization, adds only DUST to an already-authorized transaction, and stops gracefully. The standard-4 planning example compares USD 133.23 for 720 active hours with USD 22.20 for an illustrative 120-hour monthly drain, an estimated 83.3 percent reduction; other Cloudflare services and the Proof Server are excluded."/>
           <p:cNvPicPr>
             <a:picLocks noChangeAspect="1"/>
           </p:cNvPicPr>
@@ -4620,267 +4442,14 @@
         </p:blipFill>
         <p:spPr>
           <a:xfrm>
-            <a:off x="594360" y="1737360"/>
-            <a:ext cx="7909560" cy="4453128"/>
+            <a:off x="0" y="0"/>
+            <a:ext cx="12192000" cy="6858000"/>
           </a:xfrm>
           <a:prstGeom prst="rect">
             <a:avLst/>
           </a:prstGeom>
         </p:spPr>
       </p:pic>
-      <p:sp>
-        <p:nvSpPr>
-          <p:cNvPr id="8" name="Shape 5"/>
-          <p:cNvSpPr/>
-          <p:nvPr/>
-        </p:nvSpPr>
-        <p:spPr>
-          <a:xfrm>
-            <a:off x="594360" y="1737360"/>
-            <a:ext cx="7909560" cy="4453128"/>
-          </a:xfrm>
-          <a:prstGeom prst="rect">
-            <a:avLst/>
-          </a:prstGeom>
-          <a:solidFill>
-            <a:srgbClr val="090D2F">
-              <a:alpha val="0"/>
-            </a:srgbClr>
-          </a:solidFill>
-          <a:ln w="16510">
-            <a:solidFill>
-              <a:srgbClr val="75F3E5"/>
-            </a:solidFill>
-            <a:prstDash val="solid"/>
-          </a:ln>
-        </p:spPr>
-      </p:sp>
-      <p:sp>
-        <p:nvSpPr>
-          <p:cNvPr id="9" name="Shape 6"/>
-          <p:cNvSpPr/>
-          <p:nvPr/>
-        </p:nvSpPr>
-        <p:spPr>
-          <a:xfrm>
-            <a:off x="8796528" y="1737360"/>
-            <a:ext cx="2761488" cy="1856232"/>
-          </a:xfrm>
-          <a:prstGeom prst="roundRect">
-            <a:avLst>
-              <a:gd name="adj" fmla="val 2463"/>
-            </a:avLst>
-          </a:prstGeom>
-          <a:solidFill>
-            <a:srgbClr val="111849"/>
-          </a:solidFill>
-          <a:ln w="15240">
-            <a:solidFill>
-              <a:srgbClr val="75F3E5"/>
-            </a:solidFill>
-            <a:prstDash val="solid"/>
-          </a:ln>
-        </p:spPr>
-      </p:sp>
-      <p:sp>
-        <p:nvSpPr>
-          <p:cNvPr id="10" name="Text 7"/>
-          <p:cNvSpPr/>
-          <p:nvPr/>
-        </p:nvSpPr>
-        <p:spPr>
-          <a:xfrm>
-            <a:off x="9025128" y="2048256"/>
-            <a:ext cx="2286000" cy="274320"/>
-          </a:xfrm>
-          <a:prstGeom prst="rect">
-            <a:avLst/>
-          </a:prstGeom>
-          <a:noFill/>
-          <a:ln/>
-        </p:spPr>
-        <p:txBody>
-          <a:bodyPr wrap="square" lIns="0" tIns="0" rIns="0" bIns="0" rtlCol="0" anchor="ctr"/>
-          <a:lstStyle/>
-          <a:p>
-            <a:pPr algn="ctr" indent="0" marL="0">
-              <a:buNone/>
-            </a:pPr>
-            <a:r>
-              <a:rPr lang="en-US" sz="1500" b="1" dirty="0">
-                <a:solidFill>
-                  <a:srgbClr val="75F3E5"/>
-                </a:solidFill>
-              </a:rPr>
-              <a:t>DEVICE</a:t>
-            </a:r>
-            <a:endParaRPr lang="en-US" sz="1500" dirty="0"/>
-          </a:p>
-        </p:txBody>
-      </p:sp>
-      <p:sp>
-        <p:nvSpPr>
-          <p:cNvPr id="11" name="Text 8"/>
-          <p:cNvSpPr/>
-          <p:nvPr/>
-        </p:nvSpPr>
-        <p:spPr>
-          <a:xfrm>
-            <a:off x="9070848" y="2606040"/>
-            <a:ext cx="2194560" cy="502920"/>
-          </a:xfrm>
-          <a:prstGeom prst="rect">
-            <a:avLst/>
-          </a:prstGeom>
-          <a:noFill/>
-          <a:ln/>
-        </p:spPr>
-        <p:txBody>
-          <a:bodyPr wrap="square" lIns="0" tIns="0" rIns="0" bIns="0" rtlCol="0" anchor="ctr"/>
-          <a:lstStyle/>
-          <a:p>
-            <a:pPr algn="ctr" indent="0" marL="0">
-              <a:buNone/>
-            </a:pPr>
-            <a:r>
-              <a:rPr lang="en-US" sz="1100" dirty="0">
-                <a:solidFill>
-                  <a:srgbClr val="FFFFFF"/>
-                </a:solidFill>
-              </a:rPr>
-              <a:t>Approves the exact</a:t>
-            </a:r>
-            <a:endParaRPr lang="en-US" sz="1100" dirty="0"/>
-          </a:p>
-          <a:p>
-            <a:pPr algn="ctr" indent="0" marL="0">
-              <a:buNone/>
-            </a:pPr>
-            <a:r>
-              <a:rPr lang="en-US" sz="1100" dirty="0">
-                <a:solidFill>
-                  <a:srgbClr val="FFFFFF"/>
-                </a:solidFill>
-              </a:rPr>
-              <a:t>transaction payload</a:t>
-            </a:r>
-            <a:endParaRPr lang="en-US" sz="1100" dirty="0"/>
-          </a:p>
-        </p:txBody>
-      </p:sp>
-      <p:sp>
-        <p:nvSpPr>
-          <p:cNvPr id="12" name="Shape 9"/>
-          <p:cNvSpPr/>
-          <p:nvPr/>
-        </p:nvSpPr>
-        <p:spPr>
-          <a:xfrm>
-            <a:off x="8796528" y="3886200"/>
-            <a:ext cx="2761488" cy="1856232"/>
-          </a:xfrm>
-          <a:prstGeom prst="roundRect">
-            <a:avLst>
-              <a:gd name="adj" fmla="val 2463"/>
-            </a:avLst>
-          </a:prstGeom>
-          <a:solidFill>
-            <a:srgbClr val="111849"/>
-          </a:solidFill>
-          <a:ln w="15240">
-            <a:solidFill>
-              <a:srgbClr val="FFCC6E"/>
-            </a:solidFill>
-            <a:prstDash val="solid"/>
-          </a:ln>
-        </p:spPr>
-      </p:sp>
-      <p:sp>
-        <p:nvSpPr>
-          <p:cNvPr id="13" name="Text 10"/>
-          <p:cNvSpPr/>
-          <p:nvPr/>
-        </p:nvSpPr>
-        <p:spPr>
-          <a:xfrm>
-            <a:off x="9025128" y="4197096"/>
-            <a:ext cx="2286000" cy="274320"/>
-          </a:xfrm>
-          <a:prstGeom prst="rect">
-            <a:avLst/>
-          </a:prstGeom>
-          <a:noFill/>
-          <a:ln/>
-        </p:spPr>
-        <p:txBody>
-          <a:bodyPr wrap="square" lIns="0" tIns="0" rIns="0" bIns="0" rtlCol="0" anchor="ctr"/>
-          <a:lstStyle/>
-          <a:p>
-            <a:pPr algn="ctr" indent="0" marL="0">
-              <a:buNone/>
-            </a:pPr>
-            <a:r>
-              <a:rPr lang="en-US" sz="1500" b="1" dirty="0">
-                <a:solidFill>
-                  <a:srgbClr val="FFCC6E"/>
-                </a:solidFill>
-              </a:rPr>
-              <a:t>SPONSOR WALLET</a:t>
-            </a:r>
-            <a:endParaRPr lang="en-US" sz="1500" dirty="0"/>
-          </a:p>
-        </p:txBody>
-      </p:sp>
-      <p:sp>
-        <p:nvSpPr>
-          <p:cNvPr id="14" name="Text 11"/>
-          <p:cNvSpPr/>
-          <p:nvPr/>
-        </p:nvSpPr>
-        <p:spPr>
-          <a:xfrm>
-            <a:off x="9070848" y="4754880"/>
-            <a:ext cx="2194560" cy="502920"/>
-          </a:xfrm>
-          <a:prstGeom prst="rect">
-            <a:avLst/>
-          </a:prstGeom>
-          <a:noFill/>
-          <a:ln/>
-        </p:spPr>
-        <p:txBody>
-          <a:bodyPr wrap="square" lIns="0" tIns="0" rIns="0" bIns="0" rtlCol="0" anchor="ctr"/>
-          <a:lstStyle/>
-          <a:p>
-            <a:pPr algn="ctr" indent="0" marL="0">
-              <a:buNone/>
-            </a:pPr>
-            <a:r>
-              <a:rPr lang="en-US" sz="1100" dirty="0">
-                <a:solidFill>
-                  <a:srgbClr val="FFFFFF"/>
-                </a:solidFill>
-              </a:rPr>
-              <a:t>Adds required DUST</a:t>
-            </a:r>
-            <a:endParaRPr lang="en-US" sz="1100" dirty="0"/>
-          </a:p>
-          <a:p>
-            <a:pPr algn="ctr" indent="0" marL="0">
-              <a:buNone/>
-            </a:pPr>
-            <a:r>
-              <a:rPr lang="en-US" sz="1100" dirty="0">
-                <a:solidFill>
-                  <a:srgbClr val="FFFFFF"/>
-                </a:solidFill>
-              </a:rPr>
-              <a:t>Cannot alter the payload</a:t>
-            </a:r>
-            <a:endParaRPr lang="en-US" sz="1100" dirty="0"/>
-          </a:p>
-        </p:txBody>
-      </p:sp>
     </p:spTree>
   </p:cSld>
   <p:clrMapOvr>

</xml_diff>